<commit_message>
Add OAuth integration for self-play with Anthropic and OpenAI backends
Adds OAuth token management (train/self_play/oauth.py) for exchanging
refresh tokens via Supabase, and integration tests verifying self-play
works with local mock, Anthropic Claude Haiku, and OpenAI GPT-5.4.

Co-Authored-By: Claude Opus 4.6 <noreply@anthropic.com>
</commit_message>
<xml_diff>
--- a/slides/gslides/kant_slides.pptx
+++ b/slides/gslides/kant_slides.pptx
@@ -3815,15 +3815,39 @@
           </a:p>
         </p:txBody>
       </p:sp>
-      <p:sp>
-        <p:nvSpPr>
-          <p:cNvPr id="5" name="TextBox 4"/>
+      <p:pic>
+        <p:nvPicPr>
+          <p:cNvPr id="5" name="Picture 4" descr="jakub-towarek.png"/>
+          <p:cNvPicPr>
+            <a:picLocks noChangeAspect="1"/>
+          </p:cNvPicPr>
+          <p:nvPr/>
+        </p:nvPicPr>
+        <p:blipFill>
+          <a:blip r:embed="rId2"/>
+          <a:stretch>
+            <a:fillRect/>
+          </a:stretch>
+        </p:blipFill>
+        <p:spPr>
+          <a:xfrm>
+            <a:off x="1828800" y="1371600"/>
+            <a:ext cx="1828800" cy="1828800"/>
+          </a:xfrm>
+          <a:prstGeom prst="rect">
+            <a:avLst/>
+          </a:prstGeom>
+        </p:spPr>
+      </p:pic>
+      <p:sp>
+        <p:nvSpPr>
+          <p:cNvPr id="6" name="TextBox 5"/>
           <p:cNvSpPr txBox="1"/>
           <p:nvPr/>
         </p:nvSpPr>
         <p:spPr>
           <a:xfrm>
-            <a:off x="914400" y="2286000"/>
+            <a:off x="914400" y="3657600"/>
             <a:ext cx="3200400" cy="914400"/>
           </a:xfrm>
           <a:prstGeom prst="rect">
@@ -3851,15 +3875,39 @@
           </a:p>
         </p:txBody>
       </p:sp>
-      <p:sp>
-        <p:nvSpPr>
-          <p:cNvPr id="6" name="TextBox 5"/>
+      <p:pic>
+        <p:nvPicPr>
+          <p:cNvPr id="7" name="Picture 6" descr="lukasz-bartoszcze.png"/>
+          <p:cNvPicPr>
+            <a:picLocks noChangeAspect="1"/>
+          </p:cNvPicPr>
+          <p:nvPr/>
+        </p:nvPicPr>
+        <p:blipFill>
+          <a:blip r:embed="rId3"/>
+          <a:stretch>
+            <a:fillRect/>
+          </a:stretch>
+        </p:blipFill>
+        <p:spPr>
+          <a:xfrm>
+            <a:off x="5486400" y="1371600"/>
+            <a:ext cx="1828800" cy="1828800"/>
+          </a:xfrm>
+          <a:prstGeom prst="rect">
+            <a:avLst/>
+          </a:prstGeom>
+        </p:spPr>
+      </p:pic>
+      <p:sp>
+        <p:nvSpPr>
+          <p:cNvPr id="8" name="TextBox 7"/>
           <p:cNvSpPr txBox="1"/>
           <p:nvPr/>
         </p:nvSpPr>
         <p:spPr>
           <a:xfrm>
-            <a:off x="5029200" y="2286000"/>
+            <a:off x="5029200" y="3657600"/>
             <a:ext cx="3200400" cy="914400"/>
           </a:xfrm>
           <a:prstGeom prst="rect">
@@ -3889,7 +3937,7 @@
       </p:sp>
       <p:sp>
         <p:nvSpPr>
-          <p:cNvPr id="7" name="TextBox 6"/>
+          <p:cNvPr id="9" name="TextBox 8"/>
           <p:cNvSpPr txBox="1"/>
           <p:nvPr/>
         </p:nvSpPr>

</xml_diff>

<commit_message>
Replace API key entry with OAuth tokens in Gradio app; add reauth scripts
Removes all API key textboxes from the Gradio UI and uses OAuth token
exchange (via Supabase-stored refresh tokens) for LLM opponents instead.
Adds browser-based PKCE re-authorization scripts for token renewal.

Co-Authored-By: Claude Opus 4.6 <noreply@anthropic.com>
</commit_message>
<xml_diff>
--- a/slides/gslides/kant_slides.pptx
+++ b/slides/gslides/kant_slides.pptx
@@ -19,6 +19,7 @@
     <p:sldId id="267" r:id="rId18"/>
     <p:sldId id="268" r:id="rId19"/>
     <p:sldId id="269" r:id="rId20"/>
+    <p:sldId id="270" r:id="rId21"/>
   </p:sldIdLst>
   <p:sldSz cx="9144000" cy="5143500" type="screen4x3"/>
   <p:notesSz cx="6858000" cy="9144000"/>
@@ -3342,14 +3343,14 @@
               </a:defRPr>
             </a:pPr>
             <a:r>
-              <a:t>Meta-governance: agents change the rules</a:t>
+              <a:t>Architecture</a:t>
             </a:r>
           </a:p>
         </p:txBody>
       </p:sp>
       <p:pic>
         <p:nvPicPr>
-          <p:cNvPr id="5" name="Picture 4" descr="governance_flow.png"/>
+          <p:cNvPr id="5" name="Picture 4" descr="architecture.png"/>
           <p:cNvPicPr>
             <a:picLocks noChangeAspect="1"/>
           </p:cNvPicPr>
@@ -3402,7 +3403,7 @@
               </a:defRPr>
             </a:pPr>
             <a:r>
-              <a:t>Proposal types: Parameter, Mechanic, Custom | Mechanisms: Tax, redistribute, insure, quota, veto</a:t>
+              <a:t>OpenEnv platform · Gymnasium API · WebSocket · FastAPI</a:t>
             </a:r>
           </a:p>
         </p:txBody>
@@ -3498,14 +3499,14 @@
               </a:defRPr>
             </a:pPr>
             <a:r>
-              <a:t>GRPO / DPO training pipeline</a:t>
+              <a:t>Meta-governance: agents change the rules</a:t>
             </a:r>
           </a:p>
         </p:txBody>
       </p:sp>
       <p:pic>
         <p:nvPicPr>
-          <p:cNvPr id="5" name="Picture 4" descr="training_pipeline.png"/>
+          <p:cNvPr id="5" name="Picture 4" descr="governance_flow.png"/>
           <p:cNvPicPr>
             <a:picLocks noChangeAspect="1"/>
           </p:cNvPicPr>
@@ -3558,7 +3559,7 @@
               </a:defRPr>
             </a:pPr>
             <a:r>
-              <a:t>GRPO: group relative rewards, multiple rollouts | DPO: preference pairs, no reward model</a:t>
+              <a:t>Proposal types: Parameter, Mechanic, Custom | Mechanisms: Tax, redistribute, insure, quota, veto</a:t>
             </a:r>
           </a:p>
         </p:txBody>
@@ -3654,14 +3655,14 @@
               </a:defRPr>
             </a:pPr>
             <a:r>
-              <a:t>Tournament results</a:t>
+              <a:t>GRPO / DPO training pipeline</a:t>
             </a:r>
           </a:p>
         </p:txBody>
       </p:sp>
       <p:pic>
         <p:nvPicPr>
-          <p:cNvPr id="5" name="Picture 4" descr="tournament_heatmap.png"/>
+          <p:cNvPr id="5" name="Picture 4" descr="training_pipeline.png"/>
           <p:cNvPicPr>
             <a:picLocks noChangeAspect="1"/>
           </p:cNvPicPr>
@@ -3714,7 +3715,7 @@
               </a:defRPr>
             </a:pPr>
             <a:r>
-              <a:t>Illustrative data. Full multi-model results TBD.</a:t>
+              <a:t>GRPO: group relative rewards, multiple rollouts | DPO: preference pairs, no reward model</a:t>
             </a:r>
           </a:p>
         </p:txBody>
@@ -3801,7 +3802,7 @@
           </a:bodyPr>
           <a:lstStyle/>
           <a:p>
-            <a:pPr algn="ctr">
+            <a:pPr algn="l">
               <a:defRPr sz="3600" b="1">
                 <a:solidFill>
                   <a:srgbClr val="C5FFC8"/>
@@ -3810,14 +3811,14 @@
               </a:defRPr>
             </a:pPr>
             <a:r>
-              <a:t>Team</a:t>
+              <a:t>Tournament results</a:t>
             </a:r>
           </a:p>
         </p:txBody>
       </p:sp>
       <p:pic>
         <p:nvPicPr>
-          <p:cNvPr id="5" name="Picture 4" descr="jakub-towarek.png"/>
+          <p:cNvPr id="5" name="Picture 4" descr="tournament_heatmap.png"/>
           <p:cNvPicPr>
             <a:picLocks noChangeAspect="1"/>
           </p:cNvPicPr>
@@ -3831,8 +3832,8 @@
         </p:blipFill>
         <p:spPr>
           <a:xfrm>
-            <a:off x="1828800" y="1371600"/>
-            <a:ext cx="1828800" cy="1828800"/>
+            <a:off x="1371600" y="1371600"/>
+            <a:ext cx="6400800" cy="3200400"/>
           </a:xfrm>
           <a:prstGeom prst="rect">
             <a:avLst/>
@@ -3847,8 +3848,8 @@
         </p:nvSpPr>
         <p:spPr>
           <a:xfrm>
-            <a:off x="914400" y="3657600"/>
-            <a:ext cx="3200400" cy="914400"/>
+            <a:off x="914400" y="4389120"/>
+            <a:ext cx="7315200" cy="457200"/>
           </a:xfrm>
           <a:prstGeom prst="rect">
             <a:avLst/>
@@ -3862,111 +3863,15 @@
           <a:lstStyle/>
           <a:p>
             <a:pPr algn="ctr">
-              <a:defRPr sz="2800" b="1">
-                <a:solidFill>
-                  <a:srgbClr val="FFFFFF"/>
+              <a:defRPr sz="1200" b="0">
+                <a:solidFill>
+                  <a:srgbClr val="769978"/>
                 </a:solidFill>
                 <a:latin typeface="Hubot Sans"/>
               </a:defRPr>
             </a:pPr>
             <a:r>
-              <a:t>Jakub Towarek</a:t>
-            </a:r>
-          </a:p>
-        </p:txBody>
-      </p:sp>
-      <p:pic>
-        <p:nvPicPr>
-          <p:cNvPr id="7" name="Picture 6" descr="lukasz-bartoszcze.png"/>
-          <p:cNvPicPr>
-            <a:picLocks noChangeAspect="1"/>
-          </p:cNvPicPr>
-          <p:nvPr/>
-        </p:nvPicPr>
-        <p:blipFill>
-          <a:blip r:embed="rId3"/>
-          <a:stretch>
-            <a:fillRect/>
-          </a:stretch>
-        </p:blipFill>
-        <p:spPr>
-          <a:xfrm>
-            <a:off x="5486400" y="1371600"/>
-            <a:ext cx="1828800" cy="1828800"/>
-          </a:xfrm>
-          <a:prstGeom prst="rect">
-            <a:avLst/>
-          </a:prstGeom>
-        </p:spPr>
-      </p:pic>
-      <p:sp>
-        <p:nvSpPr>
-          <p:cNvPr id="8" name="TextBox 7"/>
-          <p:cNvSpPr txBox="1"/>
-          <p:nvPr/>
-        </p:nvSpPr>
-        <p:spPr>
-          <a:xfrm>
-            <a:off x="5029200" y="3657600"/>
-            <a:ext cx="3200400" cy="914400"/>
-          </a:xfrm>
-          <a:prstGeom prst="rect">
-            <a:avLst/>
-          </a:prstGeom>
-          <a:noFill/>
-        </p:spPr>
-        <p:txBody>
-          <a:bodyPr wrap="square">
-            <a:spAutoFit/>
-          </a:bodyPr>
-          <a:lstStyle/>
-          <a:p>
-            <a:pPr algn="ctr">
-              <a:defRPr sz="2800" b="1">
-                <a:solidFill>
-                  <a:srgbClr val="FFFFFF"/>
-                </a:solidFill>
-                <a:latin typeface="Hubot Sans"/>
-              </a:defRPr>
-            </a:pPr>
-            <a:r>
-              <a:t>Lukasz Bartoszcze</a:t>
-            </a:r>
-          </a:p>
-        </p:txBody>
-      </p:sp>
-      <p:sp>
-        <p:nvSpPr>
-          <p:cNvPr id="9" name="TextBox 8"/>
-          <p:cNvSpPr txBox="1"/>
-          <p:nvPr/>
-        </p:nvSpPr>
-        <p:spPr>
-          <a:xfrm>
-            <a:off x="7315200" y="4389120"/>
-            <a:ext cx="1828800" cy="457200"/>
-          </a:xfrm>
-          <a:prstGeom prst="rect">
-            <a:avLst/>
-          </a:prstGeom>
-          <a:noFill/>
-        </p:spPr>
-        <p:txBody>
-          <a:bodyPr wrap="square">
-            <a:spAutoFit/>
-          </a:bodyPr>
-          <a:lstStyle/>
-          <a:p>
-            <a:pPr algn="r">
-              <a:defRPr sz="1200" b="0">
-                <a:solidFill>
-                  <a:srgbClr val="769978"/>
-                </a:solidFill>
-                <a:latin typeface="Hubot Sans"/>
-              </a:defRPr>
-            </a:pPr>
-            <a:r>
-              <a:t>Wisent</a:t>
+              <a:t>Illustrative data. Full multi-model results TBD.</a:t>
             </a:r>
           </a:p>
         </p:txBody>
@@ -4039,6 +3944,258 @@
         </p:nvSpPr>
         <p:spPr>
           <a:xfrm>
+            <a:off x="457200" y="274320"/>
+            <a:ext cx="8229600" cy="914400"/>
+          </a:xfrm>
+          <a:prstGeom prst="rect">
+            <a:avLst/>
+          </a:prstGeom>
+          <a:noFill/>
+        </p:spPr>
+        <p:txBody>
+          <a:bodyPr wrap="square">
+            <a:spAutoFit/>
+          </a:bodyPr>
+          <a:lstStyle/>
+          <a:p>
+            <a:pPr algn="ctr">
+              <a:defRPr sz="3600" b="1">
+                <a:solidFill>
+                  <a:srgbClr val="C5FFC8"/>
+                </a:solidFill>
+                <a:latin typeface="Hubot Sans"/>
+              </a:defRPr>
+            </a:pPr>
+            <a:r>
+              <a:t>Team</a:t>
+            </a:r>
+          </a:p>
+        </p:txBody>
+      </p:sp>
+      <p:pic>
+        <p:nvPicPr>
+          <p:cNvPr id="5" name="Picture 4" descr="jakub-towarek.png"/>
+          <p:cNvPicPr>
+            <a:picLocks noChangeAspect="1"/>
+          </p:cNvPicPr>
+          <p:nvPr/>
+        </p:nvPicPr>
+        <p:blipFill>
+          <a:blip r:embed="rId2"/>
+          <a:stretch>
+            <a:fillRect/>
+          </a:stretch>
+        </p:blipFill>
+        <p:spPr>
+          <a:xfrm>
+            <a:off x="1828800" y="1371600"/>
+            <a:ext cx="1828800" cy="1828800"/>
+          </a:xfrm>
+          <a:prstGeom prst="rect">
+            <a:avLst/>
+          </a:prstGeom>
+        </p:spPr>
+      </p:pic>
+      <p:sp>
+        <p:nvSpPr>
+          <p:cNvPr id="6" name="TextBox 5"/>
+          <p:cNvSpPr txBox="1"/>
+          <p:nvPr/>
+        </p:nvSpPr>
+        <p:spPr>
+          <a:xfrm>
+            <a:off x="914400" y="3657600"/>
+            <a:ext cx="3200400" cy="914400"/>
+          </a:xfrm>
+          <a:prstGeom prst="rect">
+            <a:avLst/>
+          </a:prstGeom>
+          <a:noFill/>
+        </p:spPr>
+        <p:txBody>
+          <a:bodyPr wrap="square">
+            <a:spAutoFit/>
+          </a:bodyPr>
+          <a:lstStyle/>
+          <a:p>
+            <a:pPr algn="ctr">
+              <a:defRPr sz="2800" b="1">
+                <a:solidFill>
+                  <a:srgbClr val="FFFFFF"/>
+                </a:solidFill>
+                <a:latin typeface="Hubot Sans"/>
+              </a:defRPr>
+            </a:pPr>
+            <a:r>
+              <a:t>Jakub Towarek</a:t>
+            </a:r>
+          </a:p>
+        </p:txBody>
+      </p:sp>
+      <p:pic>
+        <p:nvPicPr>
+          <p:cNvPr id="7" name="Picture 6" descr="lukasz-bartoszcze.png"/>
+          <p:cNvPicPr>
+            <a:picLocks noChangeAspect="1"/>
+          </p:cNvPicPr>
+          <p:nvPr/>
+        </p:nvPicPr>
+        <p:blipFill>
+          <a:blip r:embed="rId3"/>
+          <a:stretch>
+            <a:fillRect/>
+          </a:stretch>
+        </p:blipFill>
+        <p:spPr>
+          <a:xfrm>
+            <a:off x="5486400" y="1371600"/>
+            <a:ext cx="1828800" cy="1828800"/>
+          </a:xfrm>
+          <a:prstGeom prst="rect">
+            <a:avLst/>
+          </a:prstGeom>
+        </p:spPr>
+      </p:pic>
+      <p:sp>
+        <p:nvSpPr>
+          <p:cNvPr id="8" name="TextBox 7"/>
+          <p:cNvSpPr txBox="1"/>
+          <p:nvPr/>
+        </p:nvSpPr>
+        <p:spPr>
+          <a:xfrm>
+            <a:off x="5029200" y="3657600"/>
+            <a:ext cx="3200400" cy="914400"/>
+          </a:xfrm>
+          <a:prstGeom prst="rect">
+            <a:avLst/>
+          </a:prstGeom>
+          <a:noFill/>
+        </p:spPr>
+        <p:txBody>
+          <a:bodyPr wrap="square">
+            <a:spAutoFit/>
+          </a:bodyPr>
+          <a:lstStyle/>
+          <a:p>
+            <a:pPr algn="ctr">
+              <a:defRPr sz="2800" b="1">
+                <a:solidFill>
+                  <a:srgbClr val="FFFFFF"/>
+                </a:solidFill>
+                <a:latin typeface="Hubot Sans"/>
+              </a:defRPr>
+            </a:pPr>
+            <a:r>
+              <a:t>Lukasz Bartoszcze</a:t>
+            </a:r>
+          </a:p>
+        </p:txBody>
+      </p:sp>
+      <p:sp>
+        <p:nvSpPr>
+          <p:cNvPr id="9" name="TextBox 8"/>
+          <p:cNvSpPr txBox="1"/>
+          <p:nvPr/>
+        </p:nvSpPr>
+        <p:spPr>
+          <a:xfrm>
+            <a:off x="7315200" y="4389120"/>
+            <a:ext cx="1828800" cy="457200"/>
+          </a:xfrm>
+          <a:prstGeom prst="rect">
+            <a:avLst/>
+          </a:prstGeom>
+          <a:noFill/>
+        </p:spPr>
+        <p:txBody>
+          <a:bodyPr wrap="square">
+            <a:spAutoFit/>
+          </a:bodyPr>
+          <a:lstStyle/>
+          <a:p>
+            <a:pPr algn="r">
+              <a:defRPr sz="1200" b="0">
+                <a:solidFill>
+                  <a:srgbClr val="769978"/>
+                </a:solidFill>
+                <a:latin typeface="Hubot Sans"/>
+              </a:defRPr>
+            </a:pPr>
+            <a:r>
+              <a:t>Wisent</a:t>
+            </a:r>
+          </a:p>
+        </p:txBody>
+      </p:sp>
+    </p:spTree>
+  </p:cSld>
+  <p:clrMapOvr>
+    <a:masterClrMapping/>
+  </p:clrMapOvr>
+</p:sld>
+</file>
+
+<file path=ppt/slides/slide15.xml><?xml version="1.0" encoding="utf-8"?>
+<p:sld xmlns:a="http://schemas.openxmlformats.org/drawingml/2006/main" xmlns:p="http://schemas.openxmlformats.org/presentationml/2006/main" xmlns:r="http://schemas.openxmlformats.org/officeDocument/2006/relationships">
+  <p:cSld>
+    <p:bg>
+      <p:bgPr>
+        <a:solidFill>
+          <a:srgbClr val="121212"/>
+        </a:solidFill>
+        <a:effectLst/>
+      </p:bgPr>
+    </p:bg>
+    <p:spTree>
+      <p:nvGrpSpPr>
+        <p:cNvPr id="1" name=""/>
+        <p:cNvGrpSpPr/>
+        <p:nvPr/>
+      </p:nvGrpSpPr>
+      <p:grpSpPr/>
+      <p:sp>
+        <p:nvSpPr>
+          <p:cNvPr id="2" name="Title 1"/>
+          <p:cNvSpPr>
+            <a:spLocks noGrp="1"/>
+          </p:cNvSpPr>
+          <p:nvPr>
+            <p:ph type="ctrTitle"/>
+          </p:nvPr>
+        </p:nvSpPr>
+        <p:spPr/>
+        <p:txBody>
+          <a:bodyPr/>
+          <a:lstStyle/>
+          <a:p/>
+        </p:txBody>
+      </p:sp>
+      <p:sp>
+        <p:nvSpPr>
+          <p:cNvPr id="3" name="Subtitle 2"/>
+          <p:cNvSpPr>
+            <a:spLocks noGrp="1"/>
+          </p:cNvSpPr>
+          <p:nvPr>
+            <p:ph type="subTitle" idx="1"/>
+          </p:nvPr>
+        </p:nvSpPr>
+        <p:spPr/>
+        <p:txBody>
+          <a:bodyPr/>
+          <a:lstStyle/>
+          <a:p/>
+        </p:txBody>
+      </p:sp>
+      <p:sp>
+        <p:nvSpPr>
+          <p:cNvPr id="4" name="TextBox 3"/>
+          <p:cNvSpPr txBox="1"/>
+          <p:nvPr/>
+        </p:nvSpPr>
+        <p:spPr>
+          <a:xfrm>
             <a:off x="914400" y="1828800"/>
             <a:ext cx="7315200" cy="1371600"/>
           </a:xfrm>
@@ -4998,11 +5155,11 @@
               </a:defRPr>
             </a:pPr>
             <a:r>
-              <a:t>Kant: 87+ games across 9 domains</a:t>
+              <a:t>Kant: 114 games across 10 domains</a:t>
             </a:r>
             <a:br/>
             <a:r>
-              <a:t>with GRPO/DPO training and</a:t>
+              <a:t>with GRPO/DPO/self-play training and</a:t>
             </a:r>
             <a:br/>
             <a:r>
@@ -5138,7 +5295,7 @@
               </a:defRPr>
             </a:pPr>
             <a:r>
-              <a:t>87+</a:t>
+              <a:t>114</a:t>
             </a:r>
           </a:p>
         </p:txBody>
@@ -5178,7 +5335,7 @@
             </a:r>
             <a:br/>
             <a:r>
-              <a:t>9 strategic domains</a:t>
+              <a:t>10 strategic domains</a:t>
             </a:r>
           </a:p>
         </p:txBody>
@@ -5884,45 +6041,21 @@
               </a:defRPr>
             </a:pPr>
             <a:r>
-              <a:t>Architecture</a:t>
-            </a:r>
-          </a:p>
-        </p:txBody>
-      </p:sp>
-      <p:pic>
-        <p:nvPicPr>
-          <p:cNvPr id="5" name="Picture 4" descr="architecture.png"/>
-          <p:cNvPicPr>
-            <a:picLocks noChangeAspect="1"/>
-          </p:cNvPicPr>
-          <p:nvPr/>
-        </p:nvPicPr>
-        <p:blipFill>
-          <a:blip r:embed="rId2"/>
-          <a:stretch>
-            <a:fillRect/>
-          </a:stretch>
-        </p:blipFill>
-        <p:spPr>
-          <a:xfrm>
-            <a:off x="1371600" y="1371600"/>
-            <a:ext cx="6400800" cy="3200400"/>
-          </a:xfrm>
-          <a:prstGeom prst="rect">
-            <a:avLst/>
-          </a:prstGeom>
-        </p:spPr>
-      </p:pic>
-      <p:sp>
-        <p:nvSpPr>
-          <p:cNvPr id="6" name="TextBox 5"/>
+              <a:t>The Prisoner's Dilemma</a:t>
+            </a:r>
+          </a:p>
+        </p:txBody>
+      </p:sp>
+      <p:sp>
+        <p:nvSpPr>
+          <p:cNvPr id="5" name="TextBox 4"/>
           <p:cNvSpPr txBox="1"/>
           <p:nvPr/>
         </p:nvSpPr>
         <p:spPr>
           <a:xfrm>
-            <a:off x="914400" y="4389120"/>
-            <a:ext cx="7315200" cy="457200"/>
+            <a:off x="2743200" y="914400"/>
+            <a:ext cx="3657600" cy="457200"/>
           </a:xfrm>
           <a:prstGeom prst="rect">
             <a:avLst/>
@@ -5936,6 +6069,324 @@
           <a:lstStyle/>
           <a:p>
             <a:pPr algn="ctr">
+              <a:defRPr sz="1600" b="0">
+                <a:solidFill>
+                  <a:srgbClr val="769978"/>
+                </a:solidFill>
+                <a:latin typeface="Hubot Sans"/>
+              </a:defRPr>
+            </a:pPr>
+            <a:r>
+              <a:t>Player 2</a:t>
+            </a:r>
+          </a:p>
+        </p:txBody>
+      </p:sp>
+      <p:sp>
+        <p:nvSpPr>
+          <p:cNvPr id="6" name="TextBox 5"/>
+          <p:cNvSpPr txBox="1"/>
+          <p:nvPr/>
+        </p:nvSpPr>
+        <p:spPr>
+          <a:xfrm>
+            <a:off x="457200" y="2286000"/>
+            <a:ext cx="1371600" cy="457200"/>
+          </a:xfrm>
+          <a:prstGeom prst="rect">
+            <a:avLst/>
+          </a:prstGeom>
+          <a:noFill/>
+        </p:spPr>
+        <p:txBody>
+          <a:bodyPr wrap="square">
+            <a:spAutoFit/>
+          </a:bodyPr>
+          <a:lstStyle/>
+          <a:p>
+            <a:pPr algn="ctr">
+              <a:defRPr sz="1600" b="0">
+                <a:solidFill>
+                  <a:srgbClr val="769978"/>
+                </a:solidFill>
+                <a:latin typeface="Hubot Sans"/>
+              </a:defRPr>
+            </a:pPr>
+            <a:r>
+              <a:t>Player 1</a:t>
+            </a:r>
+          </a:p>
+        </p:txBody>
+      </p:sp>
+      <p:graphicFrame>
+        <p:nvGraphicFramePr>
+          <p:cNvPr id="7" name="Table 6"/>
+          <p:cNvGraphicFramePr>
+            <a:graphicFrameLocks noGrp="1"/>
+          </p:cNvGraphicFramePr>
+          <p:nvPr/>
+        </p:nvGraphicFramePr>
+        <p:xfrm>
+          <a:off x="1828800" y="1371600"/>
+          <a:ext cx="4572000" cy="1828800"/>
+        </p:xfrm>
+        <a:graphic>
+          <a:graphicData uri="http://schemas.openxmlformats.org/drawingml/2006/table">
+            <a:tbl>
+              <a:tblPr firstRow="1" bandRow="1">
+                <a:tableStyleId>{5C22544A-7EE6-4342-B048-85BDC9FD1C3A}</a:tableStyleId>
+              </a:tblPr>
+              <a:tblGrid>
+                <a:gridCol w="1524000"/>
+                <a:gridCol w="1524000"/>
+                <a:gridCol w="1524000"/>
+              </a:tblGrid>
+              <a:tr h="609600">
+                <a:tc>
+                  <a:txBody>
+                    <a:bodyPr/>
+                    <a:lstStyle/>
+                    <a:p>
+                      <a:pPr algn="ctr">
+                        <a:defRPr sz="1600" b="1">
+                          <a:solidFill>
+                            <a:srgbClr val="C5FFC8"/>
+                          </a:solidFill>
+                          <a:latin typeface="Hubot Sans"/>
+                        </a:defRPr>
+                      </a:pPr>
+                    </a:p>
+                  </a:txBody>
+                  <a:tcPr>
+                    <a:solidFill>
+                      <a:srgbClr val="2D3130"/>
+                    </a:solidFill>
+                  </a:tcPr>
+                </a:tc>
+                <a:tc>
+                  <a:txBody>
+                    <a:bodyPr/>
+                    <a:lstStyle/>
+                    <a:p>
+                      <a:pPr algn="ctr">
+                        <a:defRPr sz="1600" b="1">
+                          <a:solidFill>
+                            <a:srgbClr val="C5FFC8"/>
+                          </a:solidFill>
+                          <a:latin typeface="Hubot Sans"/>
+                        </a:defRPr>
+                      </a:pPr>
+                      <a:r>
+                        <a:t>Cooperate</a:t>
+                      </a:r>
+                    </a:p>
+                  </a:txBody>
+                  <a:tcPr>
+                    <a:solidFill>
+                      <a:srgbClr val="2D3130"/>
+                    </a:solidFill>
+                  </a:tcPr>
+                </a:tc>
+                <a:tc>
+                  <a:txBody>
+                    <a:bodyPr/>
+                    <a:lstStyle/>
+                    <a:p>
+                      <a:pPr algn="ctr">
+                        <a:defRPr sz="1600" b="1">
+                          <a:solidFill>
+                            <a:srgbClr val="C5FFC8"/>
+                          </a:solidFill>
+                          <a:latin typeface="Hubot Sans"/>
+                        </a:defRPr>
+                      </a:pPr>
+                      <a:r>
+                        <a:t>Defect</a:t>
+                      </a:r>
+                    </a:p>
+                  </a:txBody>
+                  <a:tcPr>
+                    <a:solidFill>
+                      <a:srgbClr val="2D3130"/>
+                    </a:solidFill>
+                  </a:tcPr>
+                </a:tc>
+              </a:tr>
+              <a:tr h="609600">
+                <a:tc>
+                  <a:txBody>
+                    <a:bodyPr/>
+                    <a:lstStyle/>
+                    <a:p>
+                      <a:pPr algn="ctr">
+                        <a:defRPr sz="1600" b="1">
+                          <a:solidFill>
+                            <a:srgbClr val="C5FFC8"/>
+                          </a:solidFill>
+                          <a:latin typeface="Hubot Sans"/>
+                        </a:defRPr>
+                      </a:pPr>
+                      <a:r>
+                        <a:t>Cooperate</a:t>
+                      </a:r>
+                    </a:p>
+                  </a:txBody>
+                  <a:tcPr>
+                    <a:solidFill>
+                      <a:srgbClr val="2D3130"/>
+                    </a:solidFill>
+                  </a:tcPr>
+                </a:tc>
+                <a:tc>
+                  <a:txBody>
+                    <a:bodyPr/>
+                    <a:lstStyle/>
+                    <a:p>
+                      <a:pPr algn="ctr">
+                        <a:defRPr sz="1600" b="0">
+                          <a:solidFill>
+                            <a:srgbClr val="FFFFFF"/>
+                          </a:solidFill>
+                          <a:latin typeface="Hubot Sans"/>
+                        </a:defRPr>
+                      </a:pPr>
+                      <a:r>
+                        <a:t>(3, 3)</a:t>
+                      </a:r>
+                    </a:p>
+                  </a:txBody>
+                  <a:tcPr>
+                    <a:solidFill>
+                      <a:srgbClr val="2D3130"/>
+                    </a:solidFill>
+                  </a:tcPr>
+                </a:tc>
+                <a:tc>
+                  <a:txBody>
+                    <a:bodyPr/>
+                    <a:lstStyle/>
+                    <a:p>
+                      <a:pPr algn="ctr">
+                        <a:defRPr sz="1600" b="0">
+                          <a:solidFill>
+                            <a:srgbClr val="FFFFFF"/>
+                          </a:solidFill>
+                          <a:latin typeface="Hubot Sans"/>
+                        </a:defRPr>
+                      </a:pPr>
+                      <a:r>
+                        <a:t>(0, 5)</a:t>
+                      </a:r>
+                    </a:p>
+                  </a:txBody>
+                  <a:tcPr>
+                    <a:solidFill>
+                      <a:srgbClr val="2D3130"/>
+                    </a:solidFill>
+                  </a:tcPr>
+                </a:tc>
+              </a:tr>
+              <a:tr h="609600">
+                <a:tc>
+                  <a:txBody>
+                    <a:bodyPr/>
+                    <a:lstStyle/>
+                    <a:p>
+                      <a:pPr algn="ctr">
+                        <a:defRPr sz="1600" b="1">
+                          <a:solidFill>
+                            <a:srgbClr val="C5FFC8"/>
+                          </a:solidFill>
+                          <a:latin typeface="Hubot Sans"/>
+                        </a:defRPr>
+                      </a:pPr>
+                      <a:r>
+                        <a:t>Defect</a:t>
+                      </a:r>
+                    </a:p>
+                  </a:txBody>
+                  <a:tcPr>
+                    <a:solidFill>
+                      <a:srgbClr val="2D3130"/>
+                    </a:solidFill>
+                  </a:tcPr>
+                </a:tc>
+                <a:tc>
+                  <a:txBody>
+                    <a:bodyPr/>
+                    <a:lstStyle/>
+                    <a:p>
+                      <a:pPr algn="ctr">
+                        <a:defRPr sz="1600" b="0">
+                          <a:solidFill>
+                            <a:srgbClr val="FFFFFF"/>
+                          </a:solidFill>
+                          <a:latin typeface="Hubot Sans"/>
+                        </a:defRPr>
+                      </a:pPr>
+                      <a:r>
+                        <a:t>(5, 0)</a:t>
+                      </a:r>
+                    </a:p>
+                  </a:txBody>
+                  <a:tcPr>
+                    <a:solidFill>
+                      <a:srgbClr val="2D3130"/>
+                    </a:solidFill>
+                  </a:tcPr>
+                </a:tc>
+                <a:tc>
+                  <a:txBody>
+                    <a:bodyPr/>
+                    <a:lstStyle/>
+                    <a:p>
+                      <a:pPr algn="ctr">
+                        <a:defRPr sz="1600" b="0">
+                          <a:solidFill>
+                            <a:srgbClr val="FFFFFF"/>
+                          </a:solidFill>
+                          <a:latin typeface="Hubot Sans"/>
+                        </a:defRPr>
+                      </a:pPr>
+                      <a:r>
+                        <a:t>(1, 1)</a:t>
+                      </a:r>
+                    </a:p>
+                  </a:txBody>
+                  <a:tcPr>
+                    <a:solidFill>
+                      <a:srgbClr val="2D3130"/>
+                    </a:solidFill>
+                  </a:tcPr>
+                </a:tc>
+              </a:tr>
+            </a:tbl>
+          </a:graphicData>
+        </a:graphic>
+      </p:graphicFrame>
+      <p:sp>
+        <p:nvSpPr>
+          <p:cNvPr id="8" name="TextBox 7"/>
+          <p:cNvSpPr txBox="1"/>
+          <p:nvPr/>
+        </p:nvSpPr>
+        <p:spPr>
+          <a:xfrm>
+            <a:off x="457200" y="3657600"/>
+            <a:ext cx="8229600" cy="914400"/>
+          </a:xfrm>
+          <a:prstGeom prst="rect">
+            <a:avLst/>
+          </a:prstGeom>
+          <a:noFill/>
+        </p:spPr>
+        <p:txBody>
+          <a:bodyPr wrap="square">
+            <a:spAutoFit/>
+          </a:bodyPr>
+          <a:lstStyle/>
+          <a:p>
+            <a:pPr algn="l">
               <a:defRPr sz="1200" b="0">
                 <a:solidFill>
                   <a:srgbClr val="769978"/>
@@ -5944,7 +6395,11 @@
               </a:defRPr>
             </a:pPr>
             <a:r>
-              <a:t>OpenEnv platform · Gymnasium API · WebSocket · FastAPI</a:t>
+              <a:t>Nash Equilibrium: (Defect, Defect) with payoff (1, 1)  ·  Pareto Optimum: (Cooperate, Cooperate) with payoff (3, 3)</a:t>
+            </a:r>
+            <a:br/>
+            <a:r>
+              <a:t>The tension between individual rationality and collective welfare is the core alignment challenge.</a:t>
             </a:r>
           </a:p>
         </p:txBody>

</xml_diff>